<commit_message>
docs(parte-12): validar afirmaciones tecnologicas con OneCoin
</commit_message>
<xml_diff>
--- a/classes/parte-12-osint-e-ingenieria-social/249-fundamentos-de-osint/clase-249-presentacion.pptx
+++ b/classes/parte-12-osint-e-ingenieria-social/249-fundamentos-de-osint/clase-249-presentacion.pptx
@@ -3240,7 +3240,37 @@
                   <a:srgbClr val="22282E"/>
                 </a:solidFill>
               </a:rPr>
-              <a:t>•  Ejercicio aplicado y autorizado: OSINT sobre ti mismo (autoevaluación de huella).</a:t>
+              <a:t>•  Ejercicio aplicado y autorizado, con dos fases: autoevaluación de huella y validación de una</a:t>
+            </a:r>
+          </a:p>
+          <a:p>
+            <a:pPr>
+              <a:spcAft>
+                <a:spcPts val="600"/>
+              </a:spcAft>
+            </a:pPr>
+            <a:r>
+              <a:rPr sz="1500">
+                <a:solidFill>
+                  <a:srgbClr val="22282E"/>
+                </a:solidFill>
+              </a:rPr>
+              <a:t>•  afirmación tecnológica ficticia.</a:t>
+            </a:r>
+          </a:p>
+          <a:p>
+            <a:pPr>
+              <a:spcAft>
+                <a:spcPts val="600"/>
+              </a:spcAft>
+            </a:pPr>
+            <a:r>
+              <a:rPr sz="1500">
+                <a:solidFill>
+                  <a:srgbClr val="22282E"/>
+                </a:solidFill>
+              </a:rPr>
+              <a:t>•  Fase A — huella propia</a:t>
             </a:r>
           </a:p>
           <a:p>
@@ -3301,36 +3331,6 @@
                 </a:solidFill>
               </a:rPr>
               <a:t>•  Consulta motores especializados: https://haveibeenpwned.com/ para brechas asociadas a tu correo.</a:t>
-            </a:r>
-          </a:p>
-          <a:p>
-            <a:pPr>
-              <a:spcAft>
-                <a:spcPts val="600"/>
-              </a:spcAft>
-            </a:pPr>
-            <a:r>
-              <a:rPr sz="1500">
-                <a:solidFill>
-                  <a:srgbClr val="22282E"/>
-                </a:solidFill>
-              </a:rPr>
-              <a:t>•  Revisa metadatos de una foto tuya pública con exiftool foto.jpg y anota qué revela.</a:t>
-            </a:r>
-          </a:p>
-          <a:p>
-            <a:pPr>
-              <a:spcAft>
-                <a:spcPts val="600"/>
-              </a:spcAft>
-            </a:pPr>
-            <a:r>
-              <a:rPr sz="1500">
-                <a:solidFill>
-                  <a:srgbClr val="22282E"/>
-                </a:solidFill>
-              </a:rPr>
-              <a:t>•  Procesamiento: vuelca los datos en una tabla (dato, fuente, fecha, confianza alta/media/baja).</a:t>
             </a:r>
           </a:p>
         </p:txBody>
@@ -3497,6 +3497,21 @@
               <a:t>•  Investiga la diferencia entre OSINT y "doxing" y explica dónde está la frontera legal/ética.</a:t>
             </a:r>
           </a:p>
+          <a:p>
+            <a:pPr>
+              <a:spcAft>
+                <a:spcPts val="600"/>
+              </a:spcAft>
+            </a:pPr>
+            <a:r>
+              <a:rPr sz="1500">
+                <a:solidFill>
+                  <a:srgbClr val="22282E"/>
+                </a:solidFill>
+              </a:rPr>
+              <a:t>•  Lee la comunicación del DOJ sobre OneCoin y separa en una tabla: afirmaciones comerciales,</a:t>
+            </a:r>
+          </a:p>
         </p:txBody>
       </p:sp>
     </p:spTree>
@@ -3643,7 +3658,22 @@
                   <a:srgbClr val="22282E"/>
                 </a:solidFill>
               </a:rPr>
-              <a:t>•  y el informe distingue explícitamente hechos verificados de inferencias.</a:t>
+              <a:t>•  y el informe distingue explícitamente hechos verificados de inferencias. Adjunta además la matriz</a:t>
+            </a:r>
+          </a:p>
+          <a:p>
+            <a:pPr>
+              <a:spcAft>
+                <a:spcPts val="600"/>
+              </a:spcAft>
+            </a:pPr>
+            <a:r>
+              <a:rPr sz="1500">
+                <a:solidFill>
+                  <a:srgbClr val="22282E"/>
+                </a:solidFill>
+              </a:rPr>
+              <a:t>•  de la fase B: debe rechazar la afirmación no corroborada sin atribuir fraude, autor o vulnerabilidad.</a:t>
             </a:r>
           </a:p>
         </p:txBody>
@@ -3795,6 +3825,36 @@
               <a:t>•  Datos "públicos" pero de origen ilegal — Un leak robado no es fuente lícita. Verifica la legalidad de la fuente.</a:t>
             </a:r>
           </a:p>
+          <a:p>
+            <a:pPr>
+              <a:spcAft>
+                <a:spcPts val="600"/>
+              </a:spcAft>
+            </a:pPr>
+            <a:r>
+              <a:rPr sz="1500">
+                <a:solidFill>
+                  <a:srgbClr val="22282E"/>
+                </a:solidFill>
+              </a:rPr>
+              <a:t>•  Una captura o un hash «demuestran la blockchain» — Solo preservan una representación o comparan bytes; busca verificación independiente y procedencia.</a:t>
+            </a:r>
+          </a:p>
+          <a:p>
+            <a:pPr>
+              <a:spcAft>
+                <a:spcPts val="600"/>
+              </a:spcAft>
+            </a:pPr>
+            <a:r>
+              <a:rPr sz="1500">
+                <a:solidFill>
+                  <a:srgbClr val="22282E"/>
+                </a:solidFill>
+              </a:rPr>
+              <a:t>•  «No pude verificarlo, por tanto es fraude» — La ausencia de evidencia no establece intención ni delito; limita la conclusión y escala.</a:t>
+            </a:r>
+          </a:p>
         </p:txBody>
       </p:sp>
     </p:spTree>
@@ -4136,6 +4196,21 @@
                 </a:solidFill>
               </a:rPr>
               <a:t>•  OHCHR y UC Berkeley — Berkeley Protocol on Digital Open Source Investigations. &lt;https://www.ohchr.org/sites/default/files/2022-04/OHCHRBerkeleyProtocol.pdf&gt;</a:t>
+            </a:r>
+          </a:p>
+          <a:p>
+            <a:pPr>
+              <a:spcAft>
+                <a:spcPts val="600"/>
+              </a:spcAft>
+            </a:pPr>
+            <a:r>
+              <a:rPr sz="1500">
+                <a:solidFill>
+                  <a:srgbClr val="22282E"/>
+                </a:solidFill>
+              </a:rPr>
+              <a:t>•  U.S. Department of Justice — sentencia de Karl Sebastian Greenwood y hechos establecidos sobre las afirmaciones tecnológicas de OneCoin (2023).…</a:t>
             </a:r>
           </a:p>
         </p:txBody>
@@ -4511,6 +4586,21 @@
               <a:t>•  Documentar hallazgos con procedencia, transformaciones y control de sesgos; reconocer cuándo un proceso formal exige cadena de custodia adicional.</a:t>
             </a:r>
           </a:p>
+          <a:p>
+            <a:pPr>
+              <a:spcAft>
+                <a:spcPts val="600"/>
+              </a:spcAft>
+            </a:pPr>
+            <a:r>
+              <a:rPr sz="1500">
+                <a:solidFill>
+                  <a:srgbClr val="22282E"/>
+                </a:solidFill>
+              </a:rPr>
+              <a:t>•  Validar una afirmación tecnológica pública mediante propiedades observables y fuentes independientes, sin confundir falta de verificación con prueba de fraude.</a:t>
+            </a:r>
+          </a:p>
         </p:txBody>
       </p:sp>
     </p:spTree>
@@ -5031,6 +5121,21 @@
                 </a:solidFill>
               </a:rPr>
               <a:t>•  Confianza analítica — Juicio explicado sobre la solidez de una conclusión.</a:t>
+            </a:r>
+          </a:p>
+          <a:p>
+            <a:pPr>
+              <a:spcAft>
+                <a:spcPts val="600"/>
+              </a:spcAft>
+            </a:pPr>
+            <a:r>
+              <a:rPr sz="1500">
+                <a:solidFill>
+                  <a:srgbClr val="22282E"/>
+                </a:solidFill>
+              </a:rPr>
+              <a:t>•  Propiedad verificable — Característica formulada de modo que un tercero pueda observarla o refutarla.</a:t>
             </a:r>
           </a:p>
         </p:txBody>

</xml_diff>